<commit_message>
Add consulting-pptx-skill (MIT), review rule, and apply review fixes to the deck
Co-Authored-By: Claude Sonnet 5.5 <noreply@anthropic.com>
Claude-Session: https://claude.ai/code/session_01QDAWZKG5hdKRGW2TSX6AVE
</commit_message>
<xml_diff>
--- a/slides/gaichu-com-proposal.pptx
+++ b/slides/gaichu-com-proposal.pptx
@@ -3635,7 +3635,7 @@
                 <a:latin typeface="Noto Sans JP"/>
                 <a:ea typeface="Noto Sans JP"/>
               </a:rPr>
-              <a:t>最初に任せる分野を決める</a:t>
+              <a:t>最初に任せる分野を1つ選ぶ</a:t>
             </a:r>
           </a:p>
         </p:txBody>
@@ -3800,7 +3800,7 @@
                 <a:latin typeface="Noto Sans JP"/>
                 <a:ea typeface="Noto Sans JP"/>
               </a:rPr>
-              <a:t>提案と見積りの受領を決める</a:t>
+              <a:t>提案と見積りを見て発注を判断する</a:t>
             </a:r>
           </a:p>
         </p:txBody>
@@ -4470,7 +4470,7 @@
                 <a:latin typeface="Noto Sans JP"/>
                 <a:ea typeface="Noto Sans JP"/>
               </a:rPr>
-              <a:t>要件整理(自社で担う分)</a:t>
+              <a:t>要件整理</a:t>
             </a:r>
           </a:p>
         </p:txBody>
@@ -4676,7 +4676,7 @@
                 <a:latin typeface="Noto Sans JP"/>
                 <a:ea typeface="Noto Sans JP"/>
               </a:rPr>
-              <a:t>人材選定(自社で担う分)</a:t>
+              <a:t>人材選定</a:t>
             </a:r>
           </a:p>
         </p:txBody>
@@ -4882,7 +4882,7 @@
                 <a:latin typeface="Noto Sans JP"/>
                 <a:ea typeface="Noto Sans JP"/>
               </a:rPr>
-              <a:t>進行管理(自社で担う分)</a:t>
+              <a:t>進行管理</a:t>
             </a:r>
           </a:p>
         </p:txBody>
@@ -5088,7 +5088,7 @@
                 <a:latin typeface="Noto Sans JP"/>
                 <a:ea typeface="Noto Sans JP"/>
               </a:rPr>
-              <a:t>金額交渉(自社で担う分)</a:t>
+              <a:t>金額交渉</a:t>
             </a:r>
           </a:p>
         </p:txBody>
@@ -5294,7 +5294,7 @@
                 <a:latin typeface="Noto Sans JP"/>
                 <a:ea typeface="Noto Sans JP"/>
               </a:rPr>
-              <a:t>トラブル対応(自社で担う分)</a:t>
+              <a:t>トラブル対応</a:t>
             </a:r>
           </a:p>
         </p:txBody>
@@ -7491,7 +7491,7 @@
                 <a:latin typeface="Noto Sans JP"/>
                 <a:ea typeface="Noto Sans JP"/>
               </a:rPr>
-              <a:t>1件が複数の種別・業界に入るため合計は501件にならない。実績は各フリーランスの申告で、一部の工程のみの参加を含む。担当範囲は個別に確認が必要。</a:t>
+              <a:t>種別・業界ごとの件数を足しても501件とは一致しない。実績は各フリーランスの申告で、一部の工程のみの参加を含む。担当範囲は個別に確認が必要。</a:t>
             </a:r>
           </a:p>
         </p:txBody>
@@ -7708,9 +7708,7 @@
           <a:prstGeom prst="homePlate">
             <a:avLst/>
           </a:prstGeom>
-          <a:solidFill>
-            <a:srgbClr val="FFFFFF"/>
-          </a:solidFill>
+          <a:noFill/>
           <a:ln w="19050">
             <a:solidFill>
               <a:srgbClr val="07184A"/>
@@ -7762,9 +7760,7 @@
           <a:prstGeom prst="homePlate">
             <a:avLst/>
           </a:prstGeom>
-          <a:solidFill>
-            <a:srgbClr val="FFFFFF"/>
-          </a:solidFill>
+          <a:noFill/>
           <a:ln w="19050">
             <a:solidFill>
               <a:srgbClr val="07184A"/>
@@ -7819,10 +7815,8 @@
           <a:solidFill>
             <a:srgbClr val="07184A"/>
           </a:solidFill>
-          <a:ln w="19050">
-            <a:solidFill>
-              <a:srgbClr val="07184A"/>
-            </a:solidFill>
+          <a:ln>
+            <a:noFill/>
           </a:ln>
         </p:spPr>
         <p:txBody>
@@ -7870,9 +7864,7 @@
           <a:prstGeom prst="homePlate">
             <a:avLst/>
           </a:prstGeom>
-          <a:solidFill>
-            <a:srgbClr val="FFFFFF"/>
-          </a:solidFill>
+          <a:noFill/>
           <a:ln w="19050">
             <a:solidFill>
               <a:srgbClr val="07184A"/>
@@ -8529,7 +8521,7 @@
                 <a:latin typeface="Noto Sans JP"/>
                 <a:ea typeface="Noto Sans JP"/>
               </a:rPr>
-              <a:t>最初に任せる業務分野を絞る</a:t>
+              <a:t>最初に任せる分野を1つ選ぶ</a:t>
             </a:r>
           </a:p>
         </p:txBody>
@@ -8694,7 +8686,7 @@
                 <a:latin typeface="Noto Sans JP"/>
                 <a:ea typeface="Noto Sans JP"/>
               </a:rPr>
-              <a:t>提案と見積りを確認し、契約する</a:t>
+              <a:t>提案と見積りを見て発注を判断する</a:t>
             </a:r>
           </a:p>
         </p:txBody>
@@ -9119,7 +9111,7 @@
                 <a:latin typeface="Noto Sans JP"/>
                 <a:ea typeface="Noto Sans JP"/>
               </a:rPr>
-              <a:t>提案を受けて、発注まで進めることの可否</a:t>
+              <a:t>提案を受けて、発注まで進めるか</a:t>
             </a:r>
           </a:p>
         </p:txBody>

</xml_diff>

<commit_message>
Apply review fixes to the Gaichu.com deck (2nd round)
Co-Authored-By: Claude Sonnet 5.5 <noreply@anthropic.com>
Claude-Session: https://claude.ai/code/session_01QDAWZKG5hdKRGW2TSX6AVE
</commit_message>
<xml_diff>
--- a/slides/gaichu-com-proposal.pptx
+++ b/slides/gaichu-com-proposal.pptx
@@ -3237,7 +3237,7 @@
         <p:spPr>
           <a:xfrm>
             <a:off x="647700" y="1714500"/>
-            <a:ext cx="2463800" cy="406400"/>
+            <a:ext cx="2971800" cy="406400"/>
           </a:xfrm>
           <a:prstGeom prst="rect">
             <a:avLst/>
@@ -3272,7 +3272,7 @@
         </p:nvSpPr>
         <p:spPr>
           <a:xfrm>
-            <a:off x="3314700" y="1714500"/>
+            <a:off x="3822700" y="1714500"/>
             <a:ext cx="2082800" cy="406400"/>
           </a:xfrm>
           <a:prstGeom prst="rect">
@@ -3308,8 +3308,8 @@
         </p:nvSpPr>
         <p:spPr>
           <a:xfrm>
-            <a:off x="5600700" y="1714500"/>
-            <a:ext cx="4622800" cy="406400"/>
+            <a:off x="6108700" y="1714500"/>
+            <a:ext cx="4114800" cy="406400"/>
           </a:xfrm>
           <a:prstGeom prst="rect">
             <a:avLst/>
@@ -3402,7 +3402,7 @@
         <p:spPr>
           <a:xfrm>
             <a:off x="647700" y="2120900"/>
-            <a:ext cx="2463800" cy="1308100"/>
+            <a:ext cx="2971800" cy="1308100"/>
           </a:xfrm>
           <a:prstGeom prst="rect">
             <a:avLst/>
@@ -3424,7 +3424,7 @@
                 <a:latin typeface="Noto Sans JP"/>
                 <a:ea typeface="Noto Sans JP"/>
               </a:rPr>
-              <a:t>① 外注の入口を専属PM経由にするか</a:t>
+              <a:t>論点1 外注の入口を専属PM経由にするか</a:t>
             </a:r>
           </a:p>
         </p:txBody>
@@ -3437,7 +3437,7 @@
         </p:nvSpPr>
         <p:spPr>
           <a:xfrm>
-            <a:off x="3314700" y="2120900"/>
+            <a:off x="3822700" y="2120900"/>
             <a:ext cx="2082800" cy="1308100"/>
           </a:xfrm>
           <a:prstGeom prst="rect">
@@ -3473,8 +3473,8 @@
         </p:nvSpPr>
         <p:spPr>
           <a:xfrm>
-            <a:off x="5600700" y="2120900"/>
-            <a:ext cx="4622800" cy="1308100"/>
+            <a:off x="6108700" y="2120900"/>
+            <a:ext cx="4114800" cy="1308100"/>
           </a:xfrm>
           <a:prstGeom prst="rect">
             <a:avLst/>
@@ -3506,7 +3506,7 @@
                 <a:latin typeface="Noto Sans JP"/>
                 <a:ea typeface="Noto Sans JP"/>
               </a:rPr>
-              <a:t>が要件整理・人材選定・進行管理・金額交渉・トラブル対応を担当する。</a:t>
+              <a:t>が要件整理から金額交渉・トラブル対応まで担当するため、要件が固まっていなくても始められる。</a:t>
             </a:r>
           </a:p>
         </p:txBody>
@@ -3577,7 +3577,7 @@
         <p:spPr>
           <a:xfrm>
             <a:off x="647700" y="3429000"/>
-            <a:ext cx="2463800" cy="1308100"/>
+            <a:ext cx="2971800" cy="1308100"/>
           </a:xfrm>
           <a:prstGeom prst="rect">
             <a:avLst/>
@@ -3599,7 +3599,7 @@
                 <a:latin typeface="Noto Sans JP"/>
                 <a:ea typeface="Noto Sans JP"/>
               </a:rPr>
-              <a:t>② どの業務分野から任せるか</a:t>
+              <a:t>論点2 どの業務分野から任せるか</a:t>
             </a:r>
           </a:p>
         </p:txBody>
@@ -3612,7 +3612,7 @@
         </p:nvSpPr>
         <p:spPr>
           <a:xfrm>
-            <a:off x="3314700" y="3429000"/>
+            <a:off x="3822700" y="3429000"/>
             <a:ext cx="2082800" cy="1308100"/>
           </a:xfrm>
           <a:prstGeom prst="rect">
@@ -3648,8 +3648,8 @@
         </p:nvSpPr>
         <p:spPr>
           <a:xfrm>
-            <a:off x="5600700" y="3429000"/>
-            <a:ext cx="4622800" cy="1308100"/>
+            <a:off x="6108700" y="3429000"/>
+            <a:ext cx="4114800" cy="1308100"/>
           </a:xfrm>
           <a:prstGeom prst="rect">
             <a:avLst/>
@@ -3742,7 +3742,7 @@
         <p:spPr>
           <a:xfrm>
             <a:off x="647700" y="4737100"/>
-            <a:ext cx="2463800" cy="1308100"/>
+            <a:ext cx="2971800" cy="1308100"/>
           </a:xfrm>
           <a:prstGeom prst="rect">
             <a:avLst/>
@@ -3764,7 +3764,7 @@
                 <a:latin typeface="Noto Sans JP"/>
                 <a:ea typeface="Noto Sans JP"/>
               </a:rPr>
-              <a:t>③ 提案を受けて発注まで進めるか</a:t>
+              <a:t>論点3 提案を受けて発注まで進めるか</a:t>
             </a:r>
           </a:p>
         </p:txBody>
@@ -3777,7 +3777,7 @@
         </p:nvSpPr>
         <p:spPr>
           <a:xfrm>
-            <a:off x="3314700" y="4737100"/>
+            <a:off x="3822700" y="4737100"/>
             <a:ext cx="2082800" cy="1308100"/>
           </a:xfrm>
           <a:prstGeom prst="rect">
@@ -3813,8 +3813,8 @@
         </p:nvSpPr>
         <p:spPr>
           <a:xfrm>
-            <a:off x="5600700" y="4737100"/>
-            <a:ext cx="4622800" cy="1308100"/>
+            <a:off x="6108700" y="4737100"/>
+            <a:ext cx="4114800" cy="1308100"/>
           </a:xfrm>
           <a:prstGeom prst="rect">
             <a:avLst/>
@@ -4091,7 +4091,7 @@
                 <a:latin typeface="Noto Sans JP"/>
                 <a:ea typeface="Noto Sans JP"/>
               </a:rPr>
-              <a:t>人手が足りなくても、専属PMに任せれば選定から交渉までを外に出せる</a:t>
+              <a:t>人手が足りなくても、要件整理からトラブル対応まで専属PMに任せられる</a:t>
             </a:r>
           </a:p>
         </p:txBody>
@@ -4127,7 +4127,7 @@
                 <a:latin typeface="Noto Sans JP"/>
                 <a:ea typeface="Noto Sans JP"/>
               </a:rPr>
-              <a:t>現状:依頼企業が自社で担う場合</a:t>
+              <a:t>自社で担う場合(現状の仮定)</a:t>
             </a:r>
           </a:p>
         </p:txBody>
@@ -4163,7 +4163,7 @@
                 <a:latin typeface="Noto Sans JP"/>
                 <a:ea typeface="Noto Sans JP"/>
               </a:rPr>
-              <a:t>導入後:専属PMが担う場合</a:t>
+              <a:t>専属PMに任せる場合</a:t>
             </a:r>
           </a:p>
         </p:txBody>
@@ -4228,7 +4228,7 @@
                 <a:latin typeface="Noto Sans JP"/>
                 <a:ea typeface="Noto Sans JP"/>
               </a:rPr>
-              <a:t>依頼企業の声:</a:t>
+              <a:t>依頼企業の課題:</a:t>
             </a:r>
             <a:r>
               <a:rPr sz="1000" b="0">
@@ -4303,7 +4303,7 @@
                 <a:latin typeface="Noto Sans JP"/>
                 <a:ea typeface="Noto Sans JP"/>
               </a:rPr>
-              <a:t>同じ5業務を、専属PMが一括して担う</a:t>
+              <a:t>専属PMが次の5業務を担う</a:t>
             </a:r>
           </a:p>
         </p:txBody>
@@ -4404,7 +4404,7 @@
                 <a:latin typeface="Noto Sans JP"/>
                 <a:ea typeface="Noto Sans JP"/>
               </a:rPr>
-              <a:t>自社工数:xx時間</a:t>
+              <a:t>依頼企業が担当</a:t>
             </a:r>
           </a:p>
         </p:txBody>
@@ -4490,7 +4490,7 @@
             <a:avLst/>
           </a:prstGeom>
           <a:solidFill>
-            <a:srgbClr val="4C597D"/>
+            <a:srgbClr val="07184A"/>
           </a:solidFill>
           <a:ln>
             <a:noFill/>
@@ -4610,7 +4610,7 @@
                 <a:latin typeface="Noto Sans JP"/>
                 <a:ea typeface="Noto Sans JP"/>
               </a:rPr>
-              <a:t>自社工数:xx時間</a:t>
+              <a:t>依頼企業が担当</a:t>
             </a:r>
           </a:p>
         </p:txBody>
@@ -4696,7 +4696,7 @@
             <a:avLst/>
           </a:prstGeom>
           <a:solidFill>
-            <a:srgbClr val="4C597D"/>
+            <a:srgbClr val="07184A"/>
           </a:solidFill>
           <a:ln>
             <a:noFill/>
@@ -4816,7 +4816,7 @@
                 <a:latin typeface="Noto Sans JP"/>
                 <a:ea typeface="Noto Sans JP"/>
               </a:rPr>
-              <a:t>自社工数:xx時間</a:t>
+              <a:t>依頼企業が担当</a:t>
             </a:r>
           </a:p>
         </p:txBody>
@@ -4902,7 +4902,7 @@
             <a:avLst/>
           </a:prstGeom>
           <a:solidFill>
-            <a:srgbClr val="4C597D"/>
+            <a:srgbClr val="07184A"/>
           </a:solidFill>
           <a:ln>
             <a:noFill/>
@@ -5022,7 +5022,7 @@
                 <a:latin typeface="Noto Sans JP"/>
                 <a:ea typeface="Noto Sans JP"/>
               </a:rPr>
-              <a:t>自社工数:xx時間</a:t>
+              <a:t>依頼企業が担当</a:t>
             </a:r>
           </a:p>
         </p:txBody>
@@ -5228,7 +5228,7 @@
                 <a:latin typeface="Noto Sans JP"/>
                 <a:ea typeface="Noto Sans JP"/>
               </a:rPr>
-              <a:t>自社工数:xx時間</a:t>
+              <a:t>依頼企業が担当</a:t>
             </a:r>
           </a:p>
         </p:txBody>
@@ -5398,7 +5398,7 @@
                 <a:latin typeface="Noto Sans JP"/>
                 <a:ea typeface="Noto Sans JP"/>
               </a:rPr>
-              <a:t>現状の担い手を依頼企業とするのは比較のための前提で、工数の実数は素材が無いため「xx」とした。</a:t>
+              <a:t>現状の担い手を依頼企業とするのは、比較のための前提である。</a:t>
             </a:r>
           </a:p>
         </p:txBody>
@@ -5560,7 +5560,7 @@
                 <a:latin typeface="Noto Sans JP"/>
                 <a:ea typeface="Noto Sans JP"/>
               </a:rPr>
-              <a:t>制作実績501件の過半がHP制作のため、Web制作は実績を見て人を選べる</a:t>
+              <a:t>実績501件のうち323件がHP制作で、Web制作は近い実績の人を探せる</a:t>
             </a:r>
           </a:p>
         </p:txBody>
@@ -7377,7 +7377,7 @@
                 <a:latin typeface="Noto Sans JP"/>
                 <a:ea typeface="Noto Sans JP"/>
               </a:rPr>
-              <a:t>業界ごとの実績を見て、依頼内容に近い制作者を選べる。</a:t>
+              <a:t>業界ごとの実績から、依頼内容に近い制作者を探せる。</a:t>
             </a:r>
           </a:p>
         </p:txBody>
@@ -7653,7 +7653,7 @@
                 <a:latin typeface="Noto Sans JP"/>
                 <a:ea typeface="Noto Sans JP"/>
               </a:rPr>
-              <a:t>契約までは5営業日程度で済むため、提案と見積りを見て発注を決めるべきだ</a:t>
+              <a:t>提案と見積りを見たうえで発注を判断でき、契約まで5営業日程度で進む</a:t>
             </a:r>
           </a:p>
         </p:txBody>
@@ -7793,7 +7793,7 @@
                 <a:latin typeface="Noto Sans JP"/>
                 <a:ea typeface="Noto Sans JP"/>
               </a:rPr>
-              <a:t>期間:xx日</a:t>
+              <a:t>課題・目的・ご予算・スケジュール</a:t>
             </a:r>
           </a:p>
         </p:txBody>
@@ -7897,7 +7897,7 @@
                 <a:latin typeface="Noto Sans JP"/>
                 <a:ea typeface="Noto Sans JP"/>
               </a:rPr>
-              <a:t>期間:xx日</a:t>
+              <a:t>専属PMのサポートで開始</a:t>
             </a:r>
           </a:p>
         </p:txBody>
@@ -8320,7 +8320,7 @@
                 <a:latin typeface="Noto Sans JP"/>
                 <a:ea typeface="Noto Sans JP"/>
               </a:rPr>
-              <a:t>① 外注の入口</a:t>
+              <a:t>論点1 外注の入口</a:t>
             </a:r>
           </a:p>
         </p:txBody>
@@ -8485,7 +8485,7 @@
                 <a:latin typeface="Noto Sans JP"/>
                 <a:ea typeface="Noto Sans JP"/>
               </a:rPr>
-              <a:t>② 任せる分野</a:t>
+              <a:t>論点2 任せる分野</a:t>
             </a:r>
           </a:p>
         </p:txBody>
@@ -8650,7 +8650,7 @@
                 <a:latin typeface="Noto Sans JP"/>
                 <a:ea typeface="Noto Sans JP"/>
               </a:rPr>
-              <a:t>③ 発注</a:t>
+              <a:t>論点3 発注</a:t>
             </a:r>
           </a:p>
         </p:txBody>

</xml_diff>